<commit_message>
Update pitch deck: pitch/bankrun_final_run.pptx
Co-Authored-By: Claude Opus 5.5 <noreply@anthropic.com>
</commit_message>
<xml_diff>
--- a/pitch/bankrun_final_run.pptx
+++ b/pitch/bankrun_final_run.pptx
@@ -405,7 +405,7 @@
           <a:p>
             <a:r>
               <a:rPr lang="en-US"/>
-              <a:t>We use the most simple model with the bets inputs. </a:t>
+              <a:t>We use the most simple model with the best inputs. </a:t>
             </a:r>
           </a:p>
         </p:txBody>
@@ -494,19 +494,16 @@
           <a:p>
             <a:r>
               <a:rPr lang="en-US"/>
-              <a:t>That became the core of our approach.</a:t>
-            </a:r>
-          </a:p>
-          <a:p>
-            <a:r>
-              <a:rPr lang="en-US"/>
-              <a:t>We engineer interpretable features.</a:t>
-            </a:r>
-          </a:p>
-          <a:p>
-            <a:r>
-              <a:rPr lang="en-US"/>
-              <a:t>Then we use simple linear model.</a:t>
+              <a:t>Using a linear model became the core of our approach.</a:t>
+            </a:r>
+          </a:p>
+          <a:p>
+            <a:endParaRPr lang="en-US"/>
+          </a:p>
+          <a:p>
+            <a:r>
+              <a:rPr lang="en-US"/>
+              <a:t>We focus on engineering interpretable features.</a:t>
             </a:r>
           </a:p>
           <a:p>
@@ -524,6 +521,35 @@
             <a:r>
               <a:rPr lang="en-US"/>
               <a:t>.</a:t>
+            </a:r>
+          </a:p>
+          <a:p>
+            <a:endParaRPr lang="en-US"/>
+          </a:p>
+          <a:p>
+            <a:r>
+              <a:rPr lang="en-US"/>
+              <a:t>We see behaviral patterns:</a:t>
+            </a:r>
+          </a:p>
+          <a:p>
+            <a:pPr marL="171450" indent="-171450">
+              <a:buFontTx/>
+              <a:buChar char="-"/>
+            </a:pPr>
+            <a:r>
+              <a:rPr lang="en-US"/>
+              <a:t>One that travels doesn’t cancel his subsrption</a:t>
+            </a:r>
+          </a:p>
+          <a:p>
+            <a:pPr marL="171450" indent="-171450">
+              <a:buFontTx/>
+              <a:buChar char="-"/>
+            </a:pPr>
+            <a:r>
+              <a:rPr lang="en-US"/>
+              <a:t>One that tries ist doesn’t persue it</a:t>
             </a:r>
           </a:p>
           <a:p>
@@ -610,60 +636,9 @@
           <a:lstStyle/>
           <a:p>
             <a:r>
-              <a:rPr lang="en-US"/>
-              <a:t>And there’s a second advantage: </a:t>
-            </a:r>
-            <a:r>
-              <a:rPr lang="en-US" b="1"/>
-              <a:t>scale</a:t>
-            </a:r>
-            <a:r>
-              <a:rPr lang="en-US"/>
-              <a:t>.</a:t>
-            </a:r>
-          </a:p>
-          <a:p>
-            <a:r>
-              <a:rPr lang="en-US"/>
-              <a:t>UBS doesn’t need one good forecast. It needs good forecasts across </a:t>
-            </a:r>
-            <a:r>
-              <a:rPr lang="en-US" b="1"/>
-              <a:t>millions of accounts, fast</a:t>
-            </a:r>
-            <a:r>
-              <a:rPr lang="en-US"/>
-              <a:t>.</a:t>
-            </a:r>
-          </a:p>
-          <a:p>
-            <a:r>
-              <a:rPr lang="en-US"/>
-              <a:t>A lightweight model gives us exactly that: </a:t>
-            </a:r>
-            <a:r>
-              <a:rPr lang="en-US" b="1"/>
-              <a:t>efficient scoring, low complexity, and transparency at scale.</a:t>
-            </a:r>
-            <a:endParaRPr lang="en-US"/>
-          </a:p>
-          <a:p>
-            <a:r>
-              <a:rPr lang="en-US"/>
-              <a:t>So our approach is simple:</a:t>
-            </a:r>
-          </a:p>
-          <a:p>
-            <a:r>
-              <a:rPr lang="en-US" b="1"/>
-              <a:t>Find the right features. Keep the model lean. Make the forecast understandable.</a:t>
-            </a:r>
-            <a:endParaRPr lang="en-US"/>
-          </a:p>
-          <a:p>
-            <a:endParaRPr lang="en-US"/>
-          </a:p>
-          <a:p>
+              <a:rPr lang="de-CH"/>
+              <a:t>There are more advantages</a:t>
+            </a:r>
             <a:endParaRPr/>
           </a:p>
         </p:txBody>
@@ -5682,6 +5657,85 @@
               <a:uLnTx/>
               <a:uFillTx/>
               <a:latin typeface="Cambria"/>
+              <a:ea typeface="+mn-ea"/>
+              <a:cs typeface="+mn-cs"/>
+            </a:endParaRPr>
+          </a:p>
+        </p:txBody>
+      </p:sp>
+      <p:sp>
+        <p:nvSpPr>
+          <p:cNvPr id="13" name="Bullet 1">
+            <a:extLst>
+              <a:ext uri="{FF2B5EF4-FFF2-40B4-BE49-F238E27FC236}">
+                <a16:creationId xmlns:a16="http://schemas.microsoft.com/office/drawing/2014/main" id="{BD74FA2D-DD54-8044-D96B-0D7C87EB8B2D}"/>
+              </a:ext>
+            </a:extLst>
+          </p:cNvPr>
+          <p:cNvSpPr txBox="1"/>
+          <p:nvPr/>
+        </p:nvSpPr>
+        <p:spPr>
+          <a:xfrm>
+            <a:off x="838047" y="704320"/>
+            <a:ext cx="10362895" cy="914400"/>
+          </a:xfrm>
+          <a:prstGeom prst="rect">
+            <a:avLst/>
+          </a:prstGeom>
+          <a:noFill/>
+        </p:spPr>
+        <p:txBody>
+          <a:bodyPr wrap="square" lIns="0" tIns="0" rIns="0" bIns="0" anchor="t">
+            <a:noAutofit/>
+          </a:bodyPr>
+          <a:lstStyle/>
+          <a:p>
+            <a:pPr marL="0" marR="0" lvl="0" indent="0" algn="l" defTabSz="457200" rtl="0" eaLnBrk="1" fontAlgn="auto" latinLnBrk="0" hangingPunct="1">
+              <a:lnSpc>
+                <a:spcPct val="105000"/>
+              </a:lnSpc>
+              <a:spcBef>
+                <a:spcPts val="0"/>
+              </a:spcBef>
+              <a:spcAft>
+                <a:spcPts val="0"/>
+              </a:spcAft>
+              <a:buClrTx/>
+              <a:buSzTx/>
+              <a:buFontTx/>
+              <a:buNone/>
+              <a:tabLst/>
+              <a:defRPr/>
+            </a:pPr>
+            <a:r>
+              <a:rPr kumimoji="0" lang="de-CH" sz="2800" b="1" i="0" u="none" strike="noStrike" kern="1200" cap="none" spc="0" normalizeH="0" baseline="0" noProof="0">
+                <a:ln>
+                  <a:noFill/>
+                </a:ln>
+                <a:solidFill>
+                  <a:schemeClr val="bg1"/>
+                </a:solidFill>
+                <a:effectLst/>
+                <a:uLnTx/>
+                <a:uFillTx/>
+                <a:latin typeface="Arial"/>
+                <a:ea typeface="+mn-ea"/>
+                <a:cs typeface="+mn-cs"/>
+              </a:rPr>
+              <a:t>Several benefits….</a:t>
+            </a:r>
+            <a:endParaRPr kumimoji="0" sz="2800" b="1" i="0" u="none" strike="noStrike" kern="1200" cap="none" spc="0" normalizeH="0" baseline="0" noProof="0">
+              <a:ln>
+                <a:noFill/>
+              </a:ln>
+              <a:solidFill>
+                <a:schemeClr val="bg1"/>
+              </a:solidFill>
+              <a:effectLst/>
+              <a:uLnTx/>
+              <a:uFillTx/>
+              <a:latin typeface="Arial"/>
               <a:ea typeface="+mn-ea"/>
               <a:cs typeface="+mn-cs"/>
             </a:endParaRPr>

</xml_diff>